<commit_message>
Variante 3ch: disposizione piu' ordinata e fori di fissaggio M3
- scheda 103 x 215 mm: colonne distanziate (>= 2 mm tra i riquadri), spostamenti
  multipli della griglia del router
- serigrafia: riquadri della stessa riga con bordi allineati, titoli fissi,
  sottotitoli sotto il riquadro, frecce del segnale calcolate tra i blocchi,
  avviso 41 V nel blocco ALTA TENSIONE
- 8 fori M3 metallizzati a massa (angoli e confini tra i canali)
- routing rifatto: 0 errori DRC/connettivita', monitor a 1,6 mm dai nodi sensibili
- render, PDF, presentazione aggiornati

Co-Authored-By: Claude Opus 5.5 <noreply@anthropic.com>
Claude-Session: https://claude.ai/code/session_017fc9yPsNewCQrMK8R1c8Ls
</commit_message>
<xml_diff>
--- a/docs/pitch/pitch_rivelatore_muoni.pptx
+++ b/docs/pitch/pitch_rivelatore_muoni.pptx
@@ -118,18 +118,18 @@
   <p:extLst>
     <p:ext uri="{521415D9-36F7-43E2-AB2F-B90AF26B5E84}">
       <p14:sectionLst xmlns:p14="http://schemas.microsoft.com/office/powerpoint/2010/main">
-        <p14:section name="Apertura" id="{aad16a1c-512e-7a82-fde8-10f6baaa8a3c}">
+        <p14:section name="Apertura" id="{ecef541e-8b23-df79-7f8b-b74b59c799cb}">
           <p14:sldIdLst>
             <p14:sldId id="256"/>
           </p14:sldIdLst>
         </p14:section>
-        <p14:section name="Perché" id="{4d343a18-b8b1-381c-0b70-463f8a9c3fab}">
+        <p14:section name="Perché" id="{fd3553b2-957b-2edb-8b4e-2ee3f114ae4d}">
           <p14:sldIdLst>
             <p14:sldId id="257"/>
             <p14:sldId id="258"/>
           </p14:sldIdLst>
         </p14:section>
-        <p14:section name="La scheda" id="{f79a3c96-3304-7cbc-90a6-975816236e75}">
+        <p14:section name="La scheda" id="{cf5cb8f3-980b-444e-f1c1-07dc0e9aa67c}">
           <p14:sldIdLst>
             <p14:sldId id="259"/>
             <p14:sldId id="260"/>
@@ -137,14 +137,14 @@
             <p14:sldId id="262"/>
           </p14:sldIdLst>
         </p14:section>
-        <p14:section name="Budget" id="{5a35c363-89f8-9388-fad3-4e1c8563f67f}">
+        <p14:section name="Budget" id="{62d4d43e-2c0b-a645-ab4c-fa5fa8d24c12}">
           <p14:sldIdLst>
             <p14:sldId id="263"/>
             <p14:sldId id="264"/>
             <p14:sldId id="265"/>
           </p14:sldIdLst>
         </p14:section>
-        <p14:section name="Prossimi passi" id="{3a391c62-5745-2107-80d4-d679a51451ce}">
+        <p14:section name="Prossimi passi" id="{f175d754-0374-488b-6596-f15ffd19ffd7}">
           <p14:sldIdLst>
             <p14:sldId id="266"/>
             <p14:sldId id="267"/>
@@ -2595,7 +2595,7 @@
         <p:spPr>
           <a:xfrm>
             <a:off x="6035040" y="1280160"/>
-            <a:ext cx="5760720" cy="3757808"/>
+            <a:ext cx="5760720" cy="3714197"/>
           </a:xfrm>
           <a:prstGeom prst="rect">
             <a:avLst/>
@@ -6001,7 +6001,7 @@
         <p:spPr>
           <a:xfrm>
             <a:off x="548640" y="1280160"/>
-            <a:ext cx="2696063" cy="4983480"/>
+            <a:ext cx="2755864" cy="4983480"/>
           </a:xfrm>
           <a:prstGeom prst="rect">
             <a:avLst/>
@@ -6350,7 +6350,7 @@
                   <a:schemeClr val="bg2"/>
                 </a:solidFill>
               </a:rPr>
-              <a:t>178 riferimenti e i nomi dei test point stampati in serigrafia</a:t>
+              <a:t>tutti i riferimenti e i nomi dei test point stampati in serigrafia</a:t>
             </a:r>
             <a:endParaRPr lang="en-US" sz="1600" dirty="0"/>
           </a:p>
@@ -6502,7 +6502,7 @@
                   <a:schemeClr val="accent3"/>
                 </a:solidFill>
               </a:rPr>
-              <a:t>PCB 95 × 205 mm, 2 strati, maschera nera · 131 componenti montati in fabbrica</a:t>
+              <a:t>PCB 103 × 215 mm, 2 strati, 8 fori M3 · 147 componenti montati in fabbrica</a:t>
             </a:r>
             <a:endParaRPr lang="en-US" sz="1200" dirty="0"/>
           </a:p>

</xml_diff>